<commit_message>
deck: 質押加成比率下修為 Lv.1 0%、Lv.2 +3%、Lv.3 +5%、Lv.4 +7%、Lv.5 +10%
依使用者指定調整第 10 頁示意比率（保育提撥維持質押獎勵 10%）；中英兩版重建，
設計文件、PG-EC-06 與投影片包 README 同步。

Co-Authored-By: Claude Opus 5.5 <noreply@anthropic.com>
</commit_message>
<xml_diff>
--- a/output/hackathon-flexclip-en/flexclip-v4/NeonShift_FlexClip_v4.pptx
+++ b/output/hackathon-flexclip-en/flexclip-v4/NeonShift_FlexClip_v4.pptx
@@ -5206,7 +5206,7 @@
                 </a:solidFill>
                 <a:latin typeface="Arial"/>
               </a:rPr>
-              <a:t>+5%</a:t>
+              <a:t>0%</a:t>
             </a:r>
           </a:p>
         </p:txBody>
@@ -5339,7 +5339,7 @@
                 </a:solidFill>
                 <a:latin typeface="Arial"/>
               </a:rPr>
-              <a:t>+10%</a:t>
+              <a:t>+3%</a:t>
             </a:r>
           </a:p>
         </p:txBody>
@@ -5472,7 +5472,7 @@
                 </a:solidFill>
                 <a:latin typeface="Arial"/>
               </a:rPr>
-              <a:t>+15%</a:t>
+              <a:t>+5%</a:t>
             </a:r>
           </a:p>
         </p:txBody>
@@ -5605,7 +5605,7 @@
                 </a:solidFill>
                 <a:latin typeface="Arial"/>
               </a:rPr>
-              <a:t>+20%</a:t>
+              <a:t>+7%</a:t>
             </a:r>
           </a:p>
         </p:txBody>
@@ -5738,7 +5738,7 @@
                 </a:solidFill>
                 <a:latin typeface="Arial"/>
               </a:rPr>
-              <a:t>+25%</a:t>
+              <a:t>+10%</a:t>
             </a:r>
           </a:p>
         </p:txBody>

</xml_diff>